<commit_message>
Multilingual fine-tuned DistilBERT (EN/RU/KZ) as the working model
- Retrain on sentiment-pretrained base (lxyuan ...-sentiments-student),
  keep its calibrated head, add clapAI general-domain Russian, 5 epochs
- Fix label order (0=pos, 1=neu, 2=neg) across app/data/scripts
- RU F1 0.753 -> 0.814, overall 0.764; document failure modes honestly
- Generator now actually produces Kazakh (RU prompt + KZ vocab)
- Update README, notebook (new fine-tuning section), presentation,
  requirements, screenshots, sample file
</commit_message>
<xml_diff>
--- a/presentation/presentation.pptx
+++ b/presentation/presentation.pptx
@@ -3334,7 +3334,7 @@
                 </a:solidFill>
                 <a:latin typeface="Segoe UI"/>
               </a:rPr>
-              <a:t>ML-модель классифицирует каждый отзыв (негатив / нейтрал / позитив), </a:t>
+              <a:t>Мультиязычная ML-модель (EN/RU/KZ) классифицирует каждый отзыв </a:t>
             </a:r>
             <a:r>
               <a:rPr sz="1700" b="1">
@@ -3343,7 +3343,7 @@
                 </a:solidFill>
                 <a:latin typeface="Segoe UI"/>
               </a:rPr>
-              <a:t>а LLM превращает негатив в готовый бизнес-отчёт</a:t>
+              <a:t>(негатив / нейтрал / позитив), а LLM превращает негатив в готовый бизнес-отчёт</a:t>
             </a:r>
             <a:r>
               <a:rPr sz="1700" b="0">
@@ -3527,7 +3527,7 @@
                 </a:solidFill>
                 <a:latin typeface="Segoe UI"/>
               </a:rPr>
-              <a:t>Yelp reviews (HuggingFace) · 3 класса тональности</a:t>
+              <a:t>Yelp (EN) + rureviews / MultiLingualSentiment (RU) + Kazakh reviews (KZ) · 3 класса</a:t>
             </a:r>
           </a:p>
         </p:txBody>
@@ -3608,7 +3608,7 @@
                 </a:solidFill>
                 <a:latin typeface="Segoe UI"/>
               </a:rPr>
-              <a:t>30 000</a:t>
+              <a:t>30 859</a:t>
             </a:r>
           </a:p>
         </p:txBody>
@@ -3643,7 +3643,7 @@
                 </a:solidFill>
                 <a:latin typeface="Segoe UI"/>
               </a:rPr>
-              <a:t>отзывов</a:t>
+              <a:t>отзывов (train)</a:t>
             </a:r>
           </a:p>
         </p:txBody>
@@ -3759,7 +3759,7 @@
                 </a:solidFill>
                 <a:latin typeface="Segoe UI"/>
               </a:rPr>
-              <a:t>класса</a:t>
+              <a:t>языка: EN · RU · KZ</a:t>
             </a:r>
           </a:p>
         </p:txBody>
@@ -3840,7 +3840,7 @@
                 </a:solidFill>
                 <a:latin typeface="Segoe UI"/>
               </a:rPr>
-              <a:t>10 000</a:t>
+              <a:t>3</a:t>
             </a:r>
           </a:p>
         </p:txBody>
@@ -3875,7 +3875,7 @@
                 </a:solidFill>
                 <a:latin typeface="Segoe UI"/>
               </a:rPr>
-              <a:t>на класс (баланс)</a:t>
+              <a:t>класса (баланс)</a:t>
             </a:r>
           </a:p>
         </p:txBody>
@@ -3956,7 +3956,7 @@
                 </a:solidFill>
                 <a:latin typeface="Segoe UI"/>
               </a:rPr>
-              <a:t>EN</a:t>
+              <a:t>4 250</a:t>
             </a:r>
           </a:p>
         </p:txBody>
@@ -3991,7 +3991,7 @@
                 </a:solidFill>
                 <a:latin typeface="Segoe UI"/>
               </a:rPr>
-              <a:t>язык отзывов</a:t>
+              <a:t>отзывов (test)</a:t>
             </a:r>
           </a:p>
         </p:txBody>
@@ -4026,7 +4026,7 @@
                 </a:solidFill>
                 <a:latin typeface="Segoe UI"/>
               </a:rPr>
-              <a:t>Ключевые наблюдения из EDA</a:t>
+              <a:t>Ключевые наблюдения</a:t>
             </a:r>
           </a:p>
           <a:p>
@@ -4050,7 +4050,7 @@
                 </a:solidFill>
                 <a:latin typeface="Segoe UI"/>
               </a:rPr>
-              <a:t>•  1–2★ → негатив,  3★ → нейтрал,  4–5★ → позитив (3-классовая задача)</a:t>
+              <a:t>•  EN: 1–2★ → негатив, 3★ → нейтрал, 4–5★ → позитив; классы сбалансированы</a:t>
             </a:r>
           </a:p>
           <a:p>
@@ -4062,7 +4062,7 @@
                 </a:solidFill>
                 <a:latin typeface="Segoe UI"/>
               </a:rPr>
-              <a:t>•  Длина отзывов: медиана ~130 слов, есть очень короткие и очень длинные</a:t>
+              <a:t>•  RU: 90k товарных отзывов (rureviews) + общедоменные (рестораны/организации)</a:t>
             </a:r>
           </a:p>
           <a:p>
@@ -4074,7 +4074,7 @@
                 </a:solidFill>
                 <a:latin typeface="Segoe UI"/>
               </a:rPr>
-              <a:t>•  Классы сбалансированы → можно оптимизировать F1 macro без весов</a:t>
+              <a:t>•  KZ: только 1 250 открытых отзывов (развлечения) — большие датасеты gated</a:t>
             </a:r>
           </a:p>
           <a:p>
@@ -4086,7 +4086,7 @@
                 </a:solidFill>
                 <a:latin typeface="Segoe UI"/>
               </a:rPr>
-              <a:t>•  Случайная выборка из 650k — чтобы не было кластеров по бизнесам</a:t>
+              <a:t>•  RU test — только общедоменные отзывы: это реальный сценарий приложения</a:t>
             </a:r>
           </a:p>
         </p:txBody>
@@ -4226,7 +4226,7 @@
                 </a:solidFill>
                 <a:latin typeface="Segoe UI"/>
               </a:rPr>
-              <a:t>Baseline → улучшение → сравнение</a:t>
+              <a:t>Классические модели (EN) → мультиязычный трансформер (рабочая модель)</a:t>
             </a:r>
           </a:p>
         </p:txBody>
@@ -4307,7 +4307,7 @@
                 </a:solidFill>
                 <a:latin typeface="Segoe UI"/>
               </a:rPr>
-              <a:t>Текст  →  TF-IDF (биграммы)  →  Классификатор  →  вероятности по 3 классам</a:t>
+              <a:t>Текст  →  DistilBERT multilingual (fine-tuned, sentiment-база)  →  вероятности по 3 классам  →  LLM-отчёт</a:t>
             </a:r>
           </a:p>
         </p:txBody>
@@ -4320,8 +4320,8 @@
         </p:nvSpPr>
         <p:spPr>
           <a:xfrm>
-            <a:off x="640080" y="2834640"/>
-            <a:ext cx="10972800" cy="566928"/>
+            <a:off x="640080" y="2788920"/>
+            <a:ext cx="10972800" cy="502920"/>
           </a:xfrm>
           <a:prstGeom prst="roundRect">
             <a:avLst/>
@@ -4366,8 +4366,8 @@
         </p:nvSpPr>
         <p:spPr>
           <a:xfrm>
-            <a:off x="822960" y="2834640"/>
-            <a:ext cx="6858000" cy="566928"/>
+            <a:off x="822960" y="2788920"/>
+            <a:ext cx="6858000" cy="502920"/>
           </a:xfrm>
           <a:prstGeom prst="rect">
             <a:avLst/>
@@ -4401,8 +4401,8 @@
         </p:nvSpPr>
         <p:spPr>
           <a:xfrm>
-            <a:off x="7863840" y="2834640"/>
-            <a:ext cx="1645920" cy="566928"/>
+            <a:off x="7863840" y="2788920"/>
+            <a:ext cx="1645920" cy="502920"/>
           </a:xfrm>
           <a:prstGeom prst="rect">
             <a:avLst/>
@@ -4436,8 +4436,8 @@
         </p:nvSpPr>
         <p:spPr>
           <a:xfrm>
-            <a:off x="9692640" y="2834640"/>
-            <a:ext cx="1645920" cy="566928"/>
+            <a:off x="9692640" y="2788920"/>
+            <a:ext cx="1645920" cy="502920"/>
           </a:xfrm>
           <a:prstGeom prst="rect">
             <a:avLst/>
@@ -4471,8 +4471,8 @@
         </p:nvSpPr>
         <p:spPr>
           <a:xfrm>
-            <a:off x="640080" y="3401568"/>
-            <a:ext cx="10972800" cy="566928"/>
+            <a:off x="640080" y="3291840"/>
+            <a:ext cx="10972800" cy="502920"/>
           </a:xfrm>
           <a:prstGeom prst="roundRect">
             <a:avLst/>
@@ -4517,8 +4517,8 @@
         </p:nvSpPr>
         <p:spPr>
           <a:xfrm>
-            <a:off x="822960" y="3401568"/>
-            <a:ext cx="6858000" cy="566928"/>
+            <a:off x="822960" y="3291840"/>
+            <a:ext cx="6858000" cy="502920"/>
           </a:xfrm>
           <a:prstGeom prst="rect">
             <a:avLst/>
@@ -4539,7 +4539,7 @@
                 </a:solidFill>
                 <a:latin typeface="Segoe UI"/>
               </a:rPr>
-              <a:t>Naive Bayes (униграммы, baseline)</a:t>
+              <a:t>Naive Bayes (униграммы, baseline, EN)</a:t>
             </a:r>
           </a:p>
         </p:txBody>
@@ -4552,8 +4552,8 @@
         </p:nvSpPr>
         <p:spPr>
           <a:xfrm>
-            <a:off x="7863840" y="3401568"/>
-            <a:ext cx="1645920" cy="566928"/>
+            <a:off x="7863840" y="3291840"/>
+            <a:ext cx="1645920" cy="502920"/>
           </a:xfrm>
           <a:prstGeom prst="rect">
             <a:avLst/>
@@ -4587,8 +4587,8 @@
         </p:nvSpPr>
         <p:spPr>
           <a:xfrm>
-            <a:off x="9692640" y="3401568"/>
-            <a:ext cx="1645920" cy="566928"/>
+            <a:off x="9692640" y="3291840"/>
+            <a:ext cx="1645920" cy="502920"/>
           </a:xfrm>
           <a:prstGeom prst="rect">
             <a:avLst/>
@@ -4622,8 +4622,8 @@
         </p:nvSpPr>
         <p:spPr>
           <a:xfrm>
-            <a:off x="640080" y="3968496"/>
-            <a:ext cx="10972800" cy="566928"/>
+            <a:off x="640080" y="3794760"/>
+            <a:ext cx="10972800" cy="502920"/>
           </a:xfrm>
           <a:prstGeom prst="roundRect">
             <a:avLst/>
@@ -4668,8 +4668,8 @@
         </p:nvSpPr>
         <p:spPr>
           <a:xfrm>
-            <a:off x="822960" y="3968496"/>
-            <a:ext cx="6858000" cy="566928"/>
+            <a:off x="822960" y="3794760"/>
+            <a:ext cx="6858000" cy="502920"/>
           </a:xfrm>
           <a:prstGeom prst="rect">
             <a:avLst/>
@@ -4690,7 +4690,7 @@
                 </a:solidFill>
                 <a:latin typeface="Segoe UI"/>
               </a:rPr>
-              <a:t>XGBoost (биграммы, GPU)</a:t>
+              <a:t>XGBoost (биграммы, GPU, EN)</a:t>
             </a:r>
           </a:p>
         </p:txBody>
@@ -4703,8 +4703,8 @@
         </p:nvSpPr>
         <p:spPr>
           <a:xfrm>
-            <a:off x="7863840" y="3968496"/>
-            <a:ext cx="1645920" cy="566928"/>
+            <a:off x="7863840" y="3794760"/>
+            <a:ext cx="1645920" cy="502920"/>
           </a:xfrm>
           <a:prstGeom prst="rect">
             <a:avLst/>
@@ -4738,8 +4738,8 @@
         </p:nvSpPr>
         <p:spPr>
           <a:xfrm>
-            <a:off x="9692640" y="3968496"/>
-            <a:ext cx="1645920" cy="566928"/>
+            <a:off x="9692640" y="3794760"/>
+            <a:ext cx="1645920" cy="502920"/>
           </a:xfrm>
           <a:prstGeom prst="rect">
             <a:avLst/>
@@ -4773,8 +4773,8 @@
         </p:nvSpPr>
         <p:spPr>
           <a:xfrm>
-            <a:off x="640080" y="4535424"/>
-            <a:ext cx="10972800" cy="566928"/>
+            <a:off x="640080" y="4297680"/>
+            <a:ext cx="10972800" cy="502920"/>
           </a:xfrm>
           <a:prstGeom prst="roundRect">
             <a:avLst/>
@@ -4819,8 +4819,8 @@
         </p:nvSpPr>
         <p:spPr>
           <a:xfrm>
-            <a:off x="822960" y="4535424"/>
-            <a:ext cx="6858000" cy="566928"/>
+            <a:off x="822960" y="4297680"/>
+            <a:ext cx="6858000" cy="502920"/>
           </a:xfrm>
           <a:prstGeom prst="rect">
             <a:avLst/>
@@ -4841,7 +4841,7 @@
                 </a:solidFill>
                 <a:latin typeface="Segoe UI"/>
               </a:rPr>
-              <a:t>Logistic Regression (биграммы)</a:t>
+              <a:t>Logistic Regression (биграммы, EN)</a:t>
             </a:r>
           </a:p>
         </p:txBody>
@@ -4854,8 +4854,8 @@
         </p:nvSpPr>
         <p:spPr>
           <a:xfrm>
-            <a:off x="7863840" y="4535424"/>
-            <a:ext cx="1645920" cy="566928"/>
+            <a:off x="7863840" y="4297680"/>
+            <a:ext cx="1645920" cy="502920"/>
           </a:xfrm>
           <a:prstGeom prst="rect">
             <a:avLst/>
@@ -4889,8 +4889,8 @@
         </p:nvSpPr>
         <p:spPr>
           <a:xfrm>
-            <a:off x="9692640" y="4535424"/>
-            <a:ext cx="1645920" cy="566928"/>
+            <a:off x="9692640" y="4297680"/>
+            <a:ext cx="1645920" cy="502920"/>
           </a:xfrm>
           <a:prstGeom prst="rect">
             <a:avLst/>
@@ -4924,18 +4924,18 @@
         </p:nvSpPr>
         <p:spPr>
           <a:xfrm>
-            <a:off x="640080" y="5102352"/>
-            <a:ext cx="10972800" cy="566928"/>
+            <a:off x="640080" y="4800600"/>
+            <a:ext cx="10972800" cy="502920"/>
           </a:xfrm>
           <a:prstGeom prst="roundRect">
             <a:avLst/>
           </a:prstGeom>
           <a:solidFill>
-            <a:srgbClr val="EEF0FF"/>
+            <a:srgbClr val="FBFBFE"/>
           </a:solidFill>
           <a:ln w="12700">
             <a:solidFill>
-              <a:srgbClr val="4F46E5"/>
+              <a:srgbClr val="E5E8F0"/>
             </a:solidFill>
           </a:ln>
           <a:effectLst/>
@@ -4970,8 +4970,8 @@
         </p:nvSpPr>
         <p:spPr>
           <a:xfrm>
-            <a:off x="822960" y="5102352"/>
-            <a:ext cx="6858000" cy="566928"/>
+            <a:off x="822960" y="4800600"/>
+            <a:ext cx="6858000" cy="502920"/>
           </a:xfrm>
           <a:prstGeom prst="rect">
             <a:avLst/>
@@ -4986,13 +4986,13 @@
           <a:p>
             <a:pPr algn="l"/>
             <a:r>
-              <a:rPr sz="1500" b="1">
-                <a:solidFill>
-                  <a:srgbClr val="4F46E5"/>
-                </a:solidFill>
-                <a:latin typeface="Segoe UI"/>
-              </a:rPr>
-              <a:t>LinearSVC (биграммы, calibrated)</a:t>
+              <a:rPr sz="1500" b="0">
+                <a:solidFill>
+                  <a:srgbClr val="171C2B"/>
+                </a:solidFill>
+                <a:latin typeface="Segoe UI"/>
+              </a:rPr>
+              <a:t>LinearSVC (биграммы, calibrated, EN)</a:t>
             </a:r>
           </a:p>
         </p:txBody>
@@ -5005,8 +5005,8 @@
         </p:nvSpPr>
         <p:spPr>
           <a:xfrm>
-            <a:off x="7863840" y="5102352"/>
-            <a:ext cx="1645920" cy="566928"/>
+            <a:off x="7863840" y="4800600"/>
+            <a:ext cx="1645920" cy="502920"/>
           </a:xfrm>
           <a:prstGeom prst="rect">
             <a:avLst/>
@@ -5021,9 +5021,9 @@
           <a:p>
             <a:pPr algn="ctr"/>
             <a:r>
-              <a:rPr sz="1500" b="1">
-                <a:solidFill>
-                  <a:srgbClr val="4F46E5"/>
+              <a:rPr sz="1500" b="0">
+                <a:solidFill>
+                  <a:srgbClr val="171C2B"/>
                 </a:solidFill>
                 <a:latin typeface="Segoe UI"/>
               </a:rPr>
@@ -5040,8 +5040,8 @@
         </p:nvSpPr>
         <p:spPr>
           <a:xfrm>
-            <a:off x="9692640" y="5102352"/>
-            <a:ext cx="1645920" cy="566928"/>
+            <a:off x="9692640" y="4800600"/>
+            <a:ext cx="1645920" cy="502920"/>
           </a:xfrm>
           <a:prstGeom prst="rect">
             <a:avLst/>
@@ -5056,9 +5056,9 @@
           <a:p>
             <a:pPr algn="ctr"/>
             <a:r>
-              <a:rPr sz="1500" b="1">
-                <a:solidFill>
-                  <a:srgbClr val="4F46E5"/>
+              <a:rPr sz="1500" b="0">
+                <a:solidFill>
+                  <a:srgbClr val="171C2B"/>
                 </a:solidFill>
                 <a:latin typeface="Segoe UI"/>
               </a:rPr>
@@ -5069,14 +5069,165 @@
       </p:sp>
       <p:sp>
         <p:nvSpPr>
-          <p:cNvPr id="27" name="TextBox 26"/>
+          <p:cNvPr id="27" name="Rounded Rectangle 26"/>
+          <p:cNvSpPr/>
+          <p:nvPr/>
+        </p:nvSpPr>
+        <p:spPr>
+          <a:xfrm>
+            <a:off x="640080" y="5303520"/>
+            <a:ext cx="10972800" cy="502920"/>
+          </a:xfrm>
+          <a:prstGeom prst="roundRect">
+            <a:avLst/>
+          </a:prstGeom>
+          <a:solidFill>
+            <a:srgbClr val="EEF0FF"/>
+          </a:solidFill>
+          <a:ln w="12700">
+            <a:solidFill>
+              <a:srgbClr val="4F46E5"/>
+            </a:solidFill>
+          </a:ln>
+          <a:effectLst/>
+        </p:spPr>
+        <p:style>
+          <a:lnRef idx="1">
+            <a:schemeClr val="accent1"/>
+          </a:lnRef>
+          <a:fillRef idx="3">
+            <a:schemeClr val="accent1"/>
+          </a:fillRef>
+          <a:effectRef idx="2">
+            <a:schemeClr val="accent1"/>
+          </a:effectRef>
+          <a:fontRef idx="minor">
+            <a:schemeClr val="lt1"/>
+          </a:fontRef>
+        </p:style>
+        <p:txBody>
+          <a:bodyPr rtlCol="0" anchor="ctr"/>
+          <a:lstStyle/>
+          <a:p>
+            <a:pPr algn="ctr"/>
+          </a:p>
+        </p:txBody>
+      </p:sp>
+      <p:sp>
+        <p:nvSpPr>
+          <p:cNvPr id="28" name="TextBox 27"/>
           <p:cNvSpPr txBox="1"/>
           <p:nvPr/>
         </p:nvSpPr>
         <p:spPr>
           <a:xfrm>
-            <a:off x="640080" y="5943600"/>
-            <a:ext cx="10972800" cy="731520"/>
+            <a:off x="822960" y="5303520"/>
+            <a:ext cx="6858000" cy="502920"/>
+          </a:xfrm>
+          <a:prstGeom prst="rect">
+            <a:avLst/>
+          </a:prstGeom>
+          <a:noFill/>
+        </p:spPr>
+        <p:txBody>
+          <a:bodyPr wrap="square" anchor="ctr">
+            <a:spAutoFit/>
+          </a:bodyPr>
+          <a:lstStyle/>
+          <a:p>
+            <a:pPr algn="l"/>
+            <a:r>
+              <a:rPr sz="1500" b="1">
+                <a:solidFill>
+                  <a:srgbClr val="4F46E5"/>
+                </a:solidFill>
+                <a:latin typeface="Segoe UI"/>
+              </a:rPr>
+              <a:t>DistilBERT multilingual (fine-tuned, EN/RU/KZ)</a:t>
+            </a:r>
+          </a:p>
+        </p:txBody>
+      </p:sp>
+      <p:sp>
+        <p:nvSpPr>
+          <p:cNvPr id="29" name="TextBox 28"/>
+          <p:cNvSpPr txBox="1"/>
+          <p:nvPr/>
+        </p:nvSpPr>
+        <p:spPr>
+          <a:xfrm>
+            <a:off x="7863840" y="5303520"/>
+            <a:ext cx="1645920" cy="502920"/>
+          </a:xfrm>
+          <a:prstGeom prst="rect">
+            <a:avLst/>
+          </a:prstGeom>
+          <a:noFill/>
+        </p:spPr>
+        <p:txBody>
+          <a:bodyPr wrap="square" anchor="ctr">
+            <a:spAutoFit/>
+          </a:bodyPr>
+          <a:lstStyle/>
+          <a:p>
+            <a:pPr algn="ctr"/>
+            <a:r>
+              <a:rPr sz="1500" b="1">
+                <a:solidFill>
+                  <a:srgbClr val="4F46E5"/>
+                </a:solidFill>
+                <a:latin typeface="Segoe UI"/>
+              </a:rPr>
+              <a:t>0.764</a:t>
+            </a:r>
+          </a:p>
+        </p:txBody>
+      </p:sp>
+      <p:sp>
+        <p:nvSpPr>
+          <p:cNvPr id="30" name="TextBox 29"/>
+          <p:cNvSpPr txBox="1"/>
+          <p:nvPr/>
+        </p:nvSpPr>
+        <p:spPr>
+          <a:xfrm>
+            <a:off x="9692640" y="5303520"/>
+            <a:ext cx="1645920" cy="502920"/>
+          </a:xfrm>
+          <a:prstGeom prst="rect">
+            <a:avLst/>
+          </a:prstGeom>
+          <a:noFill/>
+        </p:spPr>
+        <p:txBody>
+          <a:bodyPr wrap="square" anchor="ctr">
+            <a:spAutoFit/>
+          </a:bodyPr>
+          <a:lstStyle/>
+          <a:p>
+            <a:pPr algn="ctr"/>
+            <a:r>
+              <a:rPr sz="1500" b="1">
+                <a:solidFill>
+                  <a:srgbClr val="4F46E5"/>
+                </a:solidFill>
+                <a:latin typeface="Segoe UI"/>
+              </a:rPr>
+              <a:t>0.906</a:t>
+            </a:r>
+          </a:p>
+        </p:txBody>
+      </p:sp>
+      <p:sp>
+        <p:nvSpPr>
+          <p:cNvPr id="31" name="TextBox 30"/>
+          <p:cNvSpPr txBox="1"/>
+          <p:nvPr/>
+        </p:nvSpPr>
+        <p:spPr>
+          <a:xfrm>
+            <a:off x="640080" y="5897880"/>
+            <a:ext cx="10972800" cy="822960"/>
           </a:xfrm>
           <a:prstGeom prst="rect">
             <a:avLst/>
@@ -5106,16 +5257,16 @@
                 </a:solidFill>
                 <a:latin typeface="Segoe UI"/>
               </a:rPr>
-              <a:t>на разреженных TF-IDF линейные модели обгоняют градиентный бустинг — </a:t>
-            </a:r>
-            <a:r>
-              <a:rPr sz="1500" b="0">
+              <a:t>TF-IDF-модели не понимают RU/KZ (~40% — случайный уровень), поэтому рабочая модель — </a:t>
+            </a:r>
+            <a:r>
+              <a:rPr sz="1500" b="1">
                 <a:solidFill>
                   <a:srgbClr val="171C2B"/>
                 </a:solidFill>
                 <a:latin typeface="Segoe UI"/>
               </a:rPr>
-              <a:t>XGBoost переобучается на высокоразмерных бинарных признаках.</a:t>
+              <a:t>fine-tuned трансформер: RU F1 0.814, overall 0.764.</a:t>
             </a:r>
           </a:p>
         </p:txBody>
@@ -5301,7 +5452,7 @@
         <p:spPr>
           <a:xfrm>
             <a:off x="4206240" y="1417320"/>
-            <a:ext cx="2241755" cy="5212080"/>
+            <a:ext cx="2762510" cy="5212080"/>
           </a:xfrm>
           <a:prstGeom prst="rect">
             <a:avLst/>
@@ -5598,7 +5749,7 @@
                 </a:solidFill>
                 <a:latin typeface="Segoe UI"/>
               </a:rPr>
-              <a:t>•  Рабочая модель: F1 macro 0.744, ROC AUC 0.894 (лучшая из 4)</a:t>
+              <a:t>•  Рабочая модель: fine-tuned мультиязычный DistilBERT — F1 0.764 overall, RU 0.814</a:t>
             </a:r>
           </a:p>
           <a:p>
@@ -5610,7 +5761,7 @@
                 </a:solidFill>
                 <a:latin typeface="Segoe UI"/>
               </a:rPr>
-              <a:t>•  Гибридный продукт: ML-классификация + LLM-отчёт на русском</a:t>
+              <a:t>•  Гибридный продукт: ML-классификация (EN/RU/KZ) + LLM-отчёт на русском</a:t>
             </a:r>
           </a:p>
           <a:p>
@@ -5622,7 +5773,7 @@
                 </a:solidFill>
                 <a:latin typeface="Segoe UI"/>
               </a:rPr>
-              <a:t>•  Веб-интерфейс с загрузкой файлов и валидацией</a:t>
+              <a:t>•  Веб-интерфейс: файлы, ручной ввод, генерация примера через LLM</a:t>
             </a:r>
           </a:p>
           <a:p>
@@ -5670,6 +5821,18 @@
                 </a:solidFill>
                 <a:latin typeface="Segoe UI"/>
               </a:rPr>
+              <a:t>•  Обычный MLM-трансформер схлопывал всё в «нейтрал» — спасла sentiment-база + её голова</a:t>
+            </a:r>
+          </a:p>
+          <a:p>
+            <a:pPr algn="l"/>
+            <a:r>
+              <a:rPr sz="1600" b="0">
+                <a:solidFill>
+                  <a:srgbClr val="171C2B"/>
+                </a:solidFill>
+                <a:latin typeface="Segoe UI"/>
+              </a:rPr>
               <a:t>•  LLM — thinking-модель: без отключения «размышлений» content приходит пустым</a:t>
             </a:r>
           </a:p>
@@ -5682,7 +5845,7 @@
                 </a:solidFill>
                 <a:latin typeface="Segoe UI"/>
               </a:rPr>
-              <a:t>•  XGBoost на GPU: пришлось обёртывать метки (int) и подбирать параметры</a:t>
+              <a:t>•  KZ: открытых бизнес-отзывов нет — только 1 250 (развлечения), метрики завышены</a:t>
             </a:r>
           </a:p>
           <a:p>
@@ -5730,19 +5893,7 @@
                 </a:solidFill>
                 <a:latin typeface="Segoe UI"/>
               </a:rPr>
-              <a:t>•  Обучить модель на русскоязычных отзывах (сейчас ML — только EN)</a:t>
-            </a:r>
-          </a:p>
-          <a:p>
-            <a:pPr algn="l"/>
-            <a:r>
-              <a:rPr sz="1600" b="0">
-                <a:solidFill>
-                  <a:srgbClr val="171C2B"/>
-                </a:solidFill>
-                <a:latin typeface="Segoe UI"/>
-              </a:rPr>
-              <a:t>•  Fine-tuning небольшой трансформер для более высокой точности</a:t>
+              <a:t>•  Больше KZ-данных (бизнес-домен) и более крупная модель для нюансов (ирония, отрицание)</a:t>
             </a:r>
           </a:p>
           <a:p>

</xml_diff>